<commit_message>
docs: align presentations and video script with the new model
</commit_message>
<xml_diff>
--- a/docs/FR/Cout-Feature-Partage-vs-Duplication.pptx
+++ b/docs/FR/Cout-Feature-Partage-vs-Duplication.pptx
@@ -3256,7 +3256,7 @@
               </a:defRPr>
             </a:pPr>
             <a:r>
-              <a:t>Conclusions clés de l'analyse</a:t>
+              <a:t>Conclusions clés du modèle de coût</a:t>
             </a:r>
           </a:p>
         </p:txBody>
@@ -3359,7 +3359,7 @@
               </a:defRPr>
             </a:pPr>
             <a:r>
-              <a:t>DETTE TECHNIQUE</a:t>
+              <a:t>MESURÉ VS HYPOTHÈSE</a:t>
             </a:r>
           </a:p>
         </p:txBody>
@@ -3393,7 +3393,7 @@
               </a:defRPr>
             </a:pPr>
             <a:r>
-              <a:t>La duplication alimente la dette</a:t>
+              <a:t>D'où viennent les chiffres</a:t>
             </a:r>
           </a:p>
         </p:txBody>
@@ -3470,7 +3470,7 @@
               </a:defRPr>
             </a:pPr>
             <a:r>
-              <a:t>42%</a:t>
+              <a:t>4 / 7</a:t>
             </a:r>
           </a:p>
         </p:txBody>
@@ -3504,15 +3504,15 @@
               </a:defRPr>
             </a:pPr>
             <a:r>
-              <a:t>du temps dev est perdu</a:t>
+              <a:t>facteurs du modèle</a:t>
             </a:r>
             <a:br/>
             <a:r>
-              <a:t>en dette technique</a:t>
+              <a:t>reposent sur des</a:t>
             </a:r>
             <a:br/>
             <a:r>
-              <a:t>et code de mauvaise qualité</a:t>
+              <a:t>mesures publiées</a:t>
             </a:r>
           </a:p>
         </p:txBody>
@@ -3546,7 +3546,7 @@
               </a:defRPr>
             </a:pPr>
             <a:r>
-              <a:t>Stripe Developer Coefficient, 2018</a:t>
+              <a:t>COCOMO II, Krüger &amp; Berger 2020</a:t>
             </a:r>
           </a:p>
         </p:txBody>
@@ -3623,7 +3623,7 @@
               </a:defRPr>
             </a:pPr>
             <a:r>
-              <a:t>Duplication = accélérateur de dette</a:t>
+              <a:t>Hypothèses (pas de donnée solide)</a:t>
             </a:r>
           </a:p>
         </p:txBody>
@@ -3657,7 +3657,7 @@
               </a:defRPr>
             </a:pPr>
             <a:r>
-              <a:t>›  Le facteur de divergence augmente avec le temps (1.0 → 3.0-5.0 après 2 ans)</a:t>
+              <a:t>›  Copie en plus : e0 = 1,0 × la première (indice : Ray &amp; Kim)</a:t>
             </a:r>
           </a:p>
         </p:txBody>
@@ -3691,7 +3691,7 @@
               </a:defRPr>
             </a:pPr>
             <a:r>
-              <a:t>›  Le code churn double, augmentant la probabilité de bugs</a:t>
+              <a:t>›  Dérive +0,05/an, plafond 1,5× — pas d'exponentielle</a:t>
             </a:r>
           </a:p>
         </p:txBody>
@@ -3725,7 +3725,7 @@
               </a:defRPr>
             </a:pPr>
             <a:r>
-              <a:t>›  Le coût pour l'économie US : 2 410 milliards $ (CISQ 2022)</a:t>
+              <a:t>›  Coordination + montées de version : 4 %/an du build par app en plus</a:t>
             </a:r>
           </a:p>
         </p:txBody>
@@ -3759,7 +3759,7 @@
               </a:defRPr>
             </a:pPr>
             <a:r>
-              <a:t>›  Cible : Technical Debt Ratio ≤ 5% — la duplication fait exploser ce ratio</a:t>
+              <a:t>›  Nouvelle lib : 280 h de setup, 100 h/an de fonctionnement</a:t>
             </a:r>
           </a:p>
         </p:txBody>
@@ -3836,7 +3836,7 @@
               </a:defRPr>
             </a:pPr>
             <a:r>
-              <a:t>Coût des bugs selon la phase de détection</a:t>
+              <a:t>Facteurs mesurés (fourchettes publiées)</a:t>
             </a:r>
           </a:p>
         </p:txBody>
@@ -3870,7 +3870,7 @@
               </a:defRPr>
             </a:pPr>
             <a:r>
-              <a:t>Design</a:t>
+              <a:t>Généralisation</a:t>
             </a:r>
           </a:p>
         </p:txBody>
@@ -3904,7 +3904,7 @@
               </a:defRPr>
             </a:pPr>
             <a:r>
-              <a:t>1x</a:t>
+              <a:t>×1,2</a:t>
             </a:r>
           </a:p>
         </p:txBody>
@@ -3938,7 +3938,7 @@
               </a:defRPr>
             </a:pPr>
             <a:r>
-              <a:t>Implémentation</a:t>
+              <a:t>Portage</a:t>
             </a:r>
           </a:p>
         </p:txBody>
@@ -3972,7 +3972,7 @@
               </a:defRPr>
             </a:pPr>
             <a:r>
-              <a:t>3-5x</a:t>
+              <a:t>×0,65</a:t>
             </a:r>
           </a:p>
         </p:txBody>
@@ -4006,7 +4006,7 @@
               </a:defRPr>
             </a:pPr>
             <a:r>
-              <a:t>QA / Testing</a:t>
+              <a:t>Intégration</a:t>
             </a:r>
           </a:p>
         </p:txBody>
@@ -4040,7 +4040,7 @@
               </a:defRPr>
             </a:pPr>
             <a:r>
-              <a:t>5-10x</a:t>
+              <a:t>×0,2</a:t>
             </a:r>
           </a:p>
         </p:txBody>
@@ -4074,7 +4074,7 @@
               </a:defRPr>
             </a:pPr>
             <a:r>
-              <a:t>Production</a:t>
+              <a:t>Entretien / an</a:t>
             </a:r>
           </a:p>
         </p:txBody>
@@ -4108,7 +4108,7 @@
               </a:defRPr>
             </a:pPr>
             <a:r>
-              <a:t>10-30x</a:t>
+              <a:t>20 %</a:t>
             </a:r>
           </a:p>
         </p:txBody>
@@ -4142,7 +4142,7 @@
               </a:defRPr>
             </a:pPr>
             <a:r>
-              <a:t>Avec la duplication, les bugs en prod touchent potentiellement 2 codebases → coût encore amplifié</a:t>
+              <a:t>Les bugs ne sont pas chiffrés à part : la règle 1-10-100 n'est pas soutenue par les données (Menzies et al. 2017)</a:t>
             </a:r>
           </a:p>
         </p:txBody>
@@ -4279,7 +4279,7 @@
               </a:defRPr>
             </a:pPr>
             <a:r>
-              <a:t>Comparatif global</a:t>
+              <a:t>Comparatif global (% du coût de build)</a:t>
             </a:r>
           </a:p>
         </p:txBody>
@@ -4707,7 +4707,7 @@
               </a:defRPr>
             </a:pPr>
             <a:r>
-              <a:t>+30-50%</a:t>
+              <a:t>120 % + 20 % par app en plus + setup</a:t>
             </a:r>
           </a:p>
         </p:txBody>
@@ -4741,7 +4741,7 @@
               </a:defRPr>
             </a:pPr>
             <a:r>
-              <a:t>~170-220% d'une feature</a:t>
+              <a:t>100 % + 65 % par copie en plus</a:t>
             </a:r>
           </a:p>
         </p:txBody>
@@ -4904,7 +4904,7 @@
               </a:defRPr>
             </a:pPr>
             <a:r>
-              <a:t>Maintenance annuelle</a:t>
+              <a:t>Entretien annuel</a:t>
             </a:r>
           </a:p>
         </p:txBody>
@@ -4938,7 +4938,7 @@
               </a:defRPr>
             </a:pPr>
             <a:r>
-              <a:t>15-25% du dev initial</a:t>
+              <a:t>24 % + 4 % par app en plus</a:t>
             </a:r>
           </a:p>
         </p:txBody>
@@ -4972,7 +4972,7 @@
               </a:defRPr>
             </a:pPr>
             <a:r>
-              <a:t>30-50% (double)</a:t>
+              <a:t>20 % + ~20 % par copie en plus, croissant</a:t>
             </a:r>
           </a:p>
         </p:txBody>
@@ -5135,7 +5135,7 @@
               </a:defRPr>
             </a:pPr>
             <a:r>
-              <a:t>Risque de bugs</a:t>
+              <a:t>Corrections de bugs</a:t>
             </a:r>
           </a:p>
         </p:txBody>
@@ -5169,7 +5169,7 @@
               </a:defRPr>
             </a:pPr>
             <a:r>
-              <a:t>1x (source unique)</a:t>
+              <a:t>Une fois, à un seul endroit</a:t>
             </a:r>
           </a:p>
         </p:txBody>
@@ -5203,7 +5203,7 @@
               </a:defRPr>
             </a:pPr>
             <a:r>
-              <a:t>33% bugs propagés</a:t>
+              <a:t>Dans chaque copie (dans l'entretien)</a:t>
             </a:r>
           </a:p>
         </p:txBody>
@@ -5366,7 +5366,7 @@
               </a:defRPr>
             </a:pPr>
             <a:r>
-              <a:t>Cohérence UX</a:t>
+              <a:t>Cohérence</a:t>
             </a:r>
           </a:p>
         </p:txBody>
@@ -5400,7 +5400,7 @@
               </a:defRPr>
             </a:pPr>
             <a:r>
-              <a:t>Garantie</a:t>
+              <a:t>Même code, même comportement</a:t>
             </a:r>
           </a:p>
         </p:txBody>
@@ -5434,7 +5434,7 @@
               </a:defRPr>
             </a:pPr>
             <a:r>
-              <a:t>Se dégrade</a:t>
+              <a:t>Peut dériver (parfois voulu)</a:t>
             </a:r>
           </a:p>
         </p:txBody>
@@ -5597,7 +5597,7 @@
               </a:defRPr>
             </a:pPr>
             <a:r>
-              <a:t>Scalabilité (N codebases)</a:t>
+              <a:t>Chaque app en plus</a:t>
             </a:r>
           </a:p>
         </p:txBody>
@@ -5631,7 +5631,7 @@
               </a:defRPr>
             </a:pPr>
             <a:r>
-              <a:t>Excellent (linéaire)</a:t>
+              <a:t>Peu coûteuse</a:t>
             </a:r>
           </a:p>
         </p:txBody>
@@ -5665,7 +5665,7 @@
               </a:defRPr>
             </a:pPr>
             <a:r>
-              <a:t>Mauvais (N × coût)</a:t>
+              <a:t>Coûteuse</a:t>
             </a:r>
           </a:p>
         </p:txBody>
@@ -5828,7 +5828,7 @@
               </a:defRPr>
             </a:pPr>
             <a:r>
-              <a:t>Break-even</a:t>
+              <a:t>Seuil de rentabilité</a:t>
             </a:r>
           </a:p>
         </p:txBody>
@@ -5862,7 +5862,7 @@
               </a:defRPr>
             </a:pPr>
             <a:r>
-              <a:t>6-18 mois</a:t>
+              <a:t>Dès le jour 0 (cas de référence)</a:t>
             </a:r>
           </a:p>
         </p:txBody>
@@ -5896,7 +5896,7 @@
               </a:defRPr>
             </a:pPr>
             <a:r>
-              <a:t>Jamais (coûts croissants)</a:t>
+              <a:t>Gagne pour les petites features</a:t>
             </a:r>
           </a:p>
         </p:txBody>
@@ -6059,7 +6059,7 @@
               </a:defRPr>
             </a:pPr>
             <a:r>
-              <a:t>Onboarding</a:t>
+              <a:t>Risque principal</a:t>
             </a:r>
           </a:p>
         </p:txBody>
@@ -6093,7 +6093,7 @@
               </a:defRPr>
             </a:pPr>
             <a:r>
-              <a:t>Simple (1 source)</a:t>
+              <a:t>Mauvaise abstraction, breaking changes</a:t>
             </a:r>
           </a:p>
         </p:txBody>
@@ -6127,7 +6127,7 @@
               </a:defRPr>
             </a:pPr>
             <a:r>
-              <a:t>Complexe (N sources)</a:t>
+              <a:t>Corrections oubliées, dérive</a:t>
             </a:r>
           </a:p>
         </p:txBody>
@@ -6418,7 +6418,7 @@
               </a:defRPr>
             </a:pPr>
             <a:r>
-              <a:t>✓  La feature a une durée de vie &gt; 18 mois</a:t>
+              <a:t>✓  3+ apps en ont besoin (ou sont prévues)</a:t>
             </a:r>
           </a:p>
         </p:txBody>
@@ -6452,7 +6452,7 @@
               </a:defRPr>
             </a:pPr>
             <a:r>
-              <a:t>✓  Fréquence d'évolution élevée</a:t>
+              <a:t>✓  Feature volumineuse (&gt; ~800 h pour 2 apps)</a:t>
             </a:r>
           </a:p>
         </p:txBody>
@@ -6486,7 +6486,7 @@
               </a:defRPr>
             </a:pPr>
             <a:r>
-              <a:t>✓  3+ codebases consumers (ou prévues)</a:t>
+              <a:t>✓  Horizon de plusieurs années</a:t>
             </a:r>
           </a:p>
         </p:txBody>
@@ -6520,7 +6520,7 @@
               </a:defRPr>
             </a:pPr>
             <a:r>
-              <a:t>✓  La cohérence UX est critique</a:t>
+              <a:t>✓  Une lib partagée existe déjà</a:t>
             </a:r>
           </a:p>
         </p:txBody>
@@ -6554,7 +6554,7 @@
               </a:defRPr>
             </a:pPr>
             <a:r>
-              <a:t>✓  L'équipe peut investir dans le setup initial</a:t>
+              <a:t>✓  Les apps doivent se comporter pareil</a:t>
             </a:r>
           </a:p>
         </p:txBody>
@@ -6588,7 +6588,7 @@
               </a:defRPr>
             </a:pPr>
             <a:r>
-              <a:t>✓  Le système est en croissance</a:t>
+              <a:t>✓  Généralisation peu coûteuse (G ≤ ~1,3)</a:t>
             </a:r>
           </a:p>
         </p:txBody>
@@ -6708,7 +6708,7 @@
               </a:defRPr>
             </a:pPr>
             <a:r>
-              <a:t>La duplication peut convenir si :</a:t>
+              <a:t>La copie peut être meilleure si :</a:t>
             </a:r>
           </a:p>
         </p:txBody>
@@ -6742,7 +6742,7 @@
               </a:defRPr>
             </a:pPr>
             <a:r>
-              <a:t>›  Feature à durée de vie courte (&lt; 6 mois)</a:t>
+              <a:t>›  Petite feature ou horizon court</a:t>
             </a:r>
           </a:p>
         </p:txBody>
@@ -6776,7 +6776,7 @@
               </a:defRPr>
             </a:pPr>
             <a:r>
-              <a:t>›  Très peu d'évolutions prévues</a:t>
+              <a:t>›  Une nouvelle lib pour cette seule feature</a:t>
             </a:r>
           </a:p>
         </p:txBody>
@@ -6810,7 +6810,7 @@
               </a:defRPr>
             </a:pPr>
             <a:r>
-              <a:t>›  Codebases très différentes (langages, archi)</a:t>
+              <a:t>›  Les copies sont censées diverger</a:t>
             </a:r>
           </a:p>
         </p:txBody>
@@ -6844,7 +6844,7 @@
               </a:defRPr>
             </a:pPr>
             <a:r>
-              <a:t>›  Équipes totalement indépendantes</a:t>
+              <a:t>›  Apps très différentes (généraliser coûte)</a:t>
             </a:r>
           </a:p>
         </p:txBody>
@@ -6878,7 +6878,7 @@
               </a:defRPr>
             </a:pPr>
             <a:r>
-              <a:t>›  Prototype ou MVP rapide</a:t>
+              <a:t>›  Prototype ou MVP</a:t>
             </a:r>
           </a:p>
         </p:txBody>
@@ -6912,7 +6912,7 @@
               </a:defRPr>
             </a:pPr>
             <a:r>
-              <a:t>›  Pas de besoin de cohérence UX</a:t>
+              <a:t>›  Releases impossibles à coordonner</a:t>
             </a:r>
           </a:p>
         </p:txBody>
@@ -7383,7 +7383,7 @@
               </a:defRPr>
             </a:pPr>
             <a:r>
-              <a:t>Quand on développe une feature pour plusieurs codebases : vaut-il mieux partager le code ou le dupliquer ?</a:t>
+              <a:t>Quand une feature doit exister dans plusieurs apps : la construire une fois dans une lib partagée, ou la copier dans chaque app ?</a:t>
             </a:r>
           </a:p>
         </p:txBody>
@@ -7503,7 +7503,7 @@
               </a:defRPr>
             </a:pPr>
             <a:r>
-              <a:t>Impact financier réel</a:t>
+              <a:t>Tout coût suit la feature</a:t>
             </a:r>
           </a:p>
         </p:txBody>
@@ -7537,7 +7537,7 @@
               </a:defRPr>
             </a:pPr>
             <a:r>
-              <a:t>La maintenance représente 50-80% du coût total d'un logiciel. Le choix initial a un effet massif sur le long terme.</a:t>
+              <a:t>Chaque coût est une part du coût de build (heures-personnes × taux chargé). Le taux horaire ne fait jamais basculer le verdict.</a:t>
             </a:r>
           </a:p>
         </p:txBody>
@@ -7691,7 +7691,7 @@
               </a:defRPr>
             </a:pPr>
             <a:r>
-              <a:t>Chaque approche a ses avantages. L'analyse quantifie les coûts pour permettre une décision éclairée.</a:t>
+              <a:t>La taille de la feature, le nombre d'apps et l'horizon décident. Les deux options peuvent gagner ; l'analyse montre où passe la ligne.</a:t>
             </a:r>
           </a:p>
         </p:txBody>
@@ -7811,7 +7811,7 @@
               </a:defRPr>
             </a:pPr>
             <a:r>
-              <a:t>Données sourcées</a:t>
+              <a:t>Sourcé, avec ses limites</a:t>
             </a:r>
           </a:p>
         </p:txBody>
@@ -7845,7 +7845,7 @@
               </a:defRPr>
             </a:pPr>
             <a:r>
-              <a:t>Basé sur des modèles reconnus (COCOMO II), des études IEEE, et des données salariales France 2025-2026.</a:t>
+              <a:t>Modèle de réutilisation COCOMO II, Krüger &amp; Berger 2020, Ray &amp; Kim 2012, coût du travail France 2026. Les hypothèses sont signalées.</a:t>
             </a:r>
           </a:p>
         </p:txBody>
@@ -7948,7 +7948,7 @@
               </a:defRPr>
             </a:pPr>
             <a:r>
-              <a:t>CONSTAT FONDAMENTAL</a:t>
+              <a:t>CONSTAT</a:t>
             </a:r>
           </a:p>
         </p:txBody>
@@ -7982,7 +7982,7 @@
               </a:defRPr>
             </a:pPr>
             <a:r>
-              <a:t>La maintenance domine le coût total</a:t>
+              <a:t>L'entretien est un coût récurrent</a:t>
             </a:r>
           </a:p>
         </p:txBody>
@@ -8059,7 +8059,7 @@
               </a:defRPr>
             </a:pPr>
             <a:r>
-              <a:t>50-80%</a:t>
+              <a:t>~20 %/an</a:t>
             </a:r>
           </a:p>
         </p:txBody>
@@ -8093,11 +8093,11 @@
               </a:defRPr>
             </a:pPr>
             <a:r>
-              <a:t>du coût total d'un logiciel</a:t>
+              <a:t>du coût de build, par copie,</a:t>
             </a:r>
             <a:br/>
             <a:r>
-              <a:t>est de la maintenance</a:t>
+              <a:t>pour faire vivre une feature</a:t>
             </a:r>
           </a:p>
         </p:txBody>
@@ -8131,7 +8131,7 @@
               </a:defRPr>
             </a:pPr>
             <a:r>
-              <a:t>Jusqu'à 90% pour les systèmes legacy</a:t>
+              <a:t>Ordre de grandeur : règle DoD, Glass 60/60</a:t>
             </a:r>
           </a:p>
         </p:txBody>
@@ -8208,7 +8208,7 @@
               </a:defRPr>
             </a:pPr>
             <a:r>
-              <a:t>Répartition sur 5 ans</a:t>
+              <a:t>Coût sur 5 ans, une app</a:t>
             </a:r>
           </a:p>
         </p:txBody>
@@ -8242,7 +8242,7 @@
               </a:defRPr>
             </a:pPr>
             <a:r>
-              <a:t>Développement initial</a:t>
+              <a:t>Build</a:t>
             </a:r>
           </a:p>
         </p:txBody>
@@ -8276,7 +8276,7 @@
               </a:defRPr>
             </a:pPr>
             <a:r>
-              <a:t>~21% du coût total</a:t>
+              <a:t>45 360 € (50 %)</a:t>
             </a:r>
           </a:p>
         </p:txBody>
@@ -8310,7 +8310,7 @@
               </a:defRPr>
             </a:pPr>
             <a:r>
-              <a:t>Maintenance et évolution</a:t>
+              <a:t>Entretien (5 × 20 %)</a:t>
             </a:r>
           </a:p>
         </p:txBody>
@@ -8344,7 +8344,7 @@
               </a:defRPr>
             </a:pPr>
             <a:r>
-              <a:t>~79% du coût total</a:t>
+              <a:t>45 360 € (50 %)</a:t>
             </a:r>
           </a:p>
         </p:txBody>
@@ -8378,7 +8378,7 @@
               </a:defRPr>
             </a:pPr>
             <a:r>
-              <a:t>Le choix partage vs duplication impacte surtout les 79% de maintenance</a:t>
+              <a:t>Le choix se joue dans l'entretien des copies supplémentaires</a:t>
             </a:r>
           </a:p>
         </p:txBody>
@@ -8455,7 +8455,7 @@
               </a:defRPr>
             </a:pPr>
             <a:r>
-              <a:t>Conclusion : optimiser le développement initial est moins impactant qu'optimiser la maintenance</a:t>
+              <a:t>Les bugs ne sont pas chiffrés à part : les corriger fait partie de l'entretien (pas de donnée fiable pour aller plus loin)</a:t>
             </a:r>
           </a:p>
         </p:txBody>
@@ -8592,7 +8592,7 @@
               </a:defRPr>
             </a:pPr>
             <a:r>
-              <a:t>L'investissement de départ</a:t>
+              <a:t>Au départ : à peu près égal pour 2 apps</a:t>
             </a:r>
           </a:p>
         </p:txBody>
@@ -8746,7 +8746,7 @@
               </a:defRPr>
             </a:pPr>
             <a:r>
-              <a:t>›  Dev initial + surcoût généralisation : +30%</a:t>
+              <a:t>›  Build pensé pour le partage : ×1,2 (54 432 €)</a:t>
             </a:r>
           </a:p>
         </p:txBody>
@@ -8780,7 +8780,7 @@
               </a:defRPr>
             </a:pPr>
             <a:r>
-              <a:t>›  Setup infrastructure lib : 5-11 sem.</a:t>
+              <a:t>›  Branchement dans l'autre app : 20 % (9 072 €)</a:t>
             </a:r>
           </a:p>
         </p:txBody>
@@ -8814,7 +8814,7 @@
               </a:defRPr>
             </a:pPr>
             <a:r>
-              <a:t>›  CI/CD, documentation, versioning</a:t>
+              <a:t>›  Setup d'une nouvelle lib : 280 h (11 340 €)</a:t>
             </a:r>
           </a:p>
         </p:txBody>
@@ -8848,7 +8848,7 @@
               </a:defRPr>
             </a:pPr>
             <a:r>
-              <a:t>›  Total setup : ~52 000 €</a:t>
+              <a:t>›  Total initial : 74 844 €</a:t>
             </a:r>
           </a:p>
         </p:txBody>
@@ -8882,7 +8882,7 @@
               </a:defRPr>
             </a:pPr>
             <a:r>
-              <a:t>›  Investissement one-time plus élevé</a:t>
+              <a:t>›  63 504 € si la lib existe déjà</a:t>
             </a:r>
           </a:p>
         </p:txBody>
@@ -9036,7 +9036,7 @@
               </a:defRPr>
             </a:pPr>
             <a:r>
-              <a:t>›  Dev codebase A : coût de base</a:t>
+              <a:t>›  Build pour la première app : 45 360 €</a:t>
             </a:r>
           </a:p>
         </p:txBody>
@@ -9070,7 +9070,7 @@
               </a:defRPr>
             </a:pPr>
             <a:r>
-              <a:t>›  Portage codebase B : +50 à 80%</a:t>
+              <a:t>›  Copier-adapter dans l'autre : 65 % (29 484 €)</a:t>
             </a:r>
           </a:p>
         </p:txBody>
@@ -9104,7 +9104,7 @@
               </a:defRPr>
             </a:pPr>
             <a:r>
-              <a:t>›  Adaptation design, tests doublés</a:t>
+              <a:t>›  Adapter à ses conventions, ses propres tests</a:t>
             </a:r>
           </a:p>
         </p:txBody>
@@ -9138,7 +9138,7 @@
               </a:defRPr>
             </a:pPr>
             <a:r>
-              <a:t>›  Total setup : ~43 000 €</a:t>
+              <a:t>›  Total initial : 74 844 €</a:t>
             </a:r>
           </a:p>
         </p:txBody>
@@ -9172,7 +9172,7 @@
               </a:defRPr>
             </a:pPr>
             <a:r>
-              <a:t>›  Moins cher à court terme</a:t>
+              <a:t>›  Identique au partage pour 2 apps</a:t>
             </a:r>
           </a:p>
         </p:txBody>
@@ -9249,7 +9249,7 @@
               </a:defRPr>
             </a:pPr>
             <a:r>
-              <a:t>La duplication semble ~20% moins chère au départ — mais c'est un mirage</a:t>
+              <a:t>Copier n'est pas moins cher au départ — c'est l'entretien récurrent des copies supplémentaires qui décide</a:t>
             </a:r>
           </a:p>
         </p:txBody>
@@ -9352,7 +9352,7 @@
               </a:defRPr>
             </a:pPr>
             <a:r>
-              <a:t>MAINTENANCE</a:t>
+              <a:t>ENTRETIEN</a:t>
             </a:r>
           </a:p>
         </p:txBody>
@@ -9386,7 +9386,7 @@
               </a:defRPr>
             </a:pPr>
             <a:r>
-              <a:t>Le piège : des coûts qui accélèrent</a:t>
+              <a:t>Ce qui décide : l'entretien des copies</a:t>
             </a:r>
           </a:p>
         </p:txBody>
@@ -9506,7 +9506,7 @@
               </a:defRPr>
             </a:pPr>
             <a:r>
-              <a:t>Double maintenance</a:t>
+              <a:t>Chaque copie s'entretient</a:t>
             </a:r>
           </a:p>
         </p:txBody>
@@ -9540,7 +9540,7 @@
               </a:defRPr>
             </a:pPr>
             <a:r>
-              <a:t>1.8x → 2.0x</a:t>
+              <a:t>1,0×</a:t>
             </a:r>
           </a:p>
         </p:txBody>
@@ -9574,7 +9574,7 @@
               </a:defRPr>
             </a:pPr>
             <a:r>
-              <a:t>Chaque bug, chaque évolution, chaque test doit être fait 2 fois. Le facteur augmente chaque année (+0.05/an) car les copies divergent.</a:t>
+              <a:t>Une copie supplémentaire coûte à peu près autant d'entretien annuel que la première (20 % du build), synchro et corrections répétées comprises. Ray &amp; Kim : 11-16 % des changements portés entre forks.</a:t>
             </a:r>
           </a:p>
         </p:txBody>
@@ -9694,7 +9694,7 @@
               </a:defRPr>
             </a:pPr>
             <a:r>
-              <a:t>Synchronisation croissante</a:t>
+              <a:t>Les copies dérivent</a:t>
             </a:r>
           </a:p>
         </p:txBody>
@@ -9728,7 +9728,7 @@
               </a:defRPr>
             </a:pPr>
             <a:r>
-              <a:t>+20%/an</a:t>
+              <a:t>+0,05/an</a:t>
             </a:r>
           </a:p>
         </p:txBody>
@@ -9762,7 +9762,7 @@
               </a:defRPr>
             </a:pPr>
             <a:r>
-              <a:t>Le coût de synchro augmente exponentiellement. Année 1 : ~10K€, Année 3 : ~14K€, Année 5 : ~23K€. Effet boule de neige.</a:t>
+              <a:t>Hypothèse, sans donnée : l'entretien d'une copie supplémentaire augmente de 0,05 par an, plafonné à 1,5×. Pas d'exponentielle : des copies trop divergentes ne sont plus synchronisées.</a:t>
             </a:r>
           </a:p>
         </p:txBody>
@@ -9882,7 +9882,7 @@
               </a:defRPr>
             </a:pPr>
             <a:r>
-              <a:t>Bugs propagés</a:t>
+              <a:t>Entretien du partage</a:t>
             </a:r>
           </a:p>
         </p:txBody>
@@ -9916,7 +9916,7 @@
               </a:defRPr>
             </a:pPr>
             <a:r>
-              <a:t>33%</a:t>
+              <a:t>4 %/an</a:t>
             </a:r>
           </a:p>
         </p:txBody>
@@ -9950,7 +9950,7 @@
               </a:defRPr>
             </a:pPr>
             <a:r>
-              <a:t>Étude IEEE : 1/3 des bugs corrigés dans un clone ne sont jamais corrigés dans l'autre copie. Coût estimé : ~50K€/an.</a:t>
+              <a:t>Par app supplémentaire : coordination et montées de version cassantes (ordre de grandeur). Plus 24 %/an d'entretien du code partagé, plus gros, et 100 h/an pour faire tourner une nouvelle lib.</a:t>
             </a:r>
           </a:p>
         </p:txBody>
@@ -10027,7 +10027,7 @@
               </a:defRPr>
             </a:pPr>
             <a:r>
-              <a:t>La duplication n'est viable que pour des features à durée de vie courte</a:t>
+              <a:t>Cas de référence : partage 16 750 €/an vs duplication 18 144 € → 19 958 €/an, payés chaque année</a:t>
             </a:r>
           </a:p>
         </p:txBody>
@@ -10130,7 +10130,7 @@
               </a:defRPr>
             </a:pPr>
             <a:r>
-              <a:t>PROJECTION À 3 ANS</a:t>
+              <a:t>PROJECTION À 5 ANS</a:t>
             </a:r>
           </a:p>
         </p:txBody>
@@ -10164,7 +10164,7 @@
               </a:defRPr>
             </a:pPr>
             <a:r>
-              <a:t>Comparaison chiffrée (contexte France)</a:t>
+              <a:t>Scénario de référence (France 2026)</a:t>
             </a:r>
           </a:p>
         </p:txBody>
@@ -10469,7 +10469,7 @@
               </a:defRPr>
             </a:pPr>
             <a:r>
-              <a:t>Année 2</a:t>
+              <a:t>Année 3</a:t>
             </a:r>
           </a:p>
         </p:txBody>
@@ -10546,7 +10546,7 @@
               </a:defRPr>
             </a:pPr>
             <a:r>
-              <a:t>Année 3</a:t>
+              <a:t>Année 5</a:t>
             </a:r>
           </a:p>
         </p:txBody>
@@ -10743,7 +10743,7 @@
               </a:defRPr>
             </a:pPr>
             <a:r>
-              <a:t>52 000 €</a:t>
+              <a:t>74 844 €</a:t>
             </a:r>
           </a:p>
         </p:txBody>
@@ -10820,7 +10820,7 @@
               </a:defRPr>
             </a:pPr>
             <a:r>
-              <a:t>119 000 €</a:t>
+              <a:t>91 595 €</a:t>
             </a:r>
           </a:p>
         </p:txBody>
@@ -10897,7 +10897,7 @@
               </a:defRPr>
             </a:pPr>
             <a:r>
-              <a:t>186 000 €</a:t>
+              <a:t>125 096 €</a:t>
             </a:r>
           </a:p>
         </p:txBody>
@@ -10974,7 +10974,7 @@
               </a:defRPr>
             </a:pPr>
             <a:r>
-              <a:t>253 000 €</a:t>
+              <a:t>158 598 €</a:t>
             </a:r>
           </a:p>
         </p:txBody>
@@ -11171,7 +11171,7 @@
               </a:defRPr>
             </a:pPr>
             <a:r>
-              <a:t>43 000 €</a:t>
+              <a:t>74 844 €</a:t>
             </a:r>
           </a:p>
         </p:txBody>
@@ -11248,7 +11248,7 @@
               </a:defRPr>
             </a:pPr>
             <a:r>
-              <a:t>114 000 €</a:t>
+              <a:t>92 988 €</a:t>
             </a:r>
           </a:p>
         </p:txBody>
@@ -11325,7 +11325,7 @@
               </a:defRPr>
             </a:pPr>
             <a:r>
-              <a:t>187 000 €</a:t>
+              <a:t>130 637 €</a:t>
             </a:r>
           </a:p>
         </p:txBody>
@@ -11402,7 +11402,7 @@
               </a:defRPr>
             </a:pPr>
             <a:r>
-              <a:t>263 000 €</a:t>
+              <a:t>170 100 €</a:t>
             </a:r>
           </a:p>
         </p:txBody>
@@ -11470,7 +11470,7 @@
               </a:defRPr>
             </a:pPr>
             <a:r>
-              <a:t>›  Le code partagé coûte +9 000€ de plus à l'année 0 (investissement setup)</a:t>
+              <a:t>›  Année 0 : même coût initial (feature de 1 120 h, équipe à 40,50 €/h, 2 apps, nouvelle lib)</a:t>
             </a:r>
           </a:p>
         </p:txBody>
@@ -11504,7 +11504,7 @@
               </a:defRPr>
             </a:pPr>
             <a:r>
-              <a:t>›  Dès l'année 1, les coûts cumulés sont quasi identiques</a:t>
+              <a:t>›  Le partage n'est jamais plus cher : il est rentable dès le jour 0</a:t>
             </a:r>
           </a:p>
         </p:txBody>
@@ -11538,7 +11538,7 @@
               </a:defRPr>
             </a:pPr>
             <a:r>
-              <a:t>›  À partir de l'année 2, la duplication devient plus coûteuse</a:t>
+              <a:t>›  Année 5 : la duplication coûte 11 502 € de plus (7 %) — 43 092 € de plus si la lib existe déjà</a:t>
             </a:r>
           </a:p>
         </p:txBody>
@@ -11572,7 +11572,7 @@
               </a:defRPr>
             </a:pPr>
             <a:r>
-              <a:t>›  Année 3 : la duplication coûte ~10 000€ de plus — et l'écart s'accélère</a:t>
+              <a:t>›  Marge mince pour 2 apps : une généralisation G ≥ 1,33 ou un entretien de copie e0 ≤ 0,75 inverse le verdict</a:t>
             </a:r>
           </a:p>
         </p:txBody>
@@ -11675,7 +11675,7 @@
               </a:defRPr>
             </a:pPr>
             <a:r>
-              <a:t>POINT DE CROISEMENT</a:t>
+              <a:t>SEUIL DE RENTABILITÉ</a:t>
             </a:r>
           </a:p>
         </p:txBody>
@@ -11709,7 +11709,7 @@
               </a:defRPr>
             </a:pPr>
             <a:r>
-              <a:t>Quand le partage devient rentable</a:t>
+              <a:t>Lu sur les mêmes courbes de coût</a:t>
             </a:r>
           </a:p>
         </p:txBody>
@@ -11786,7 +11786,7 @@
               </a:defRPr>
             </a:pPr>
             <a:r>
-              <a:t>6 à 18 mois</a:t>
+              <a:t>Mois 0</a:t>
             </a:r>
           </a:p>
         </p:txBody>
@@ -11820,11 +11820,11 @@
               </a:defRPr>
             </a:pPr>
             <a:r>
-              <a:t>Break-even typique</a:t>
+              <a:t>Seuil de rentabilité dans</a:t>
             </a:r>
             <a:br/>
             <a:r>
-              <a:t>pour l'approche code partagé</a:t>
+              <a:t>le scénario de référence</a:t>
             </a:r>
           </a:p>
         </p:txBody>
@@ -11901,7 +11901,7 @@
               </a:defRPr>
             </a:pPr>
             <a:r>
-              <a:t>Dans notre exemple</a:t>
+              <a:t>Petite feature (140 h, nouvelle lib)</a:t>
             </a:r>
           </a:p>
         </p:txBody>
@@ -11935,7 +11935,7 @@
               </a:defRPr>
             </a:pPr>
             <a:r>
-              <a:t>~18 mois</a:t>
+              <a:t>Jamais</a:t>
             </a:r>
           </a:p>
         </p:txBody>
@@ -11969,15 +11969,15 @@
               </a:defRPr>
             </a:pPr>
             <a:r>
-              <a:t>Le surcoût initial de 26 000€ est</a:t>
+              <a:t>Sur 5 ans, le partage coûte</a:t>
             </a:r>
             <a:br/>
             <a:r>
-              <a:t>amorti par les économies mensuelles</a:t>
+              <a:t>2,2× plus cher que la copie</a:t>
             </a:r>
             <a:br/>
             <a:r>
-              <a:t>de ~1 400€/mois</a:t>
+              <a:t>(47 466 € vs 21 263 €)</a:t>
             </a:r>
           </a:p>
         </p:txBody>
@@ -12097,7 +12097,7 @@
               </a:defRPr>
             </a:pPr>
             <a:r>
-              <a:t>Raccourcit le break-even</a:t>
+              <a:t>Favorise le partage</a:t>
             </a:r>
           </a:p>
         </p:txBody>
@@ -12131,7 +12131,7 @@
               </a:defRPr>
             </a:pPr>
             <a:r>
-              <a:t>›  Feature volumineuse</a:t>
+              <a:t>›  Feature volumineuse (&gt; ~820 h pour 2 apps)</a:t>
             </a:r>
           </a:p>
         </p:txBody>
@@ -12165,7 +12165,7 @@
               </a:defRPr>
             </a:pPr>
             <a:r>
-              <a:t>›  Évolutions fréquentes</a:t>
+              <a:t>›  3+ apps (le seuil tombe à ~340 h)</a:t>
             </a:r>
           </a:p>
         </p:txBody>
@@ -12199,7 +12199,7 @@
               </a:defRPr>
             </a:pPr>
             <a:r>
-              <a:t>›  Bugs fréquents en prod</a:t>
+              <a:t>›  Une lib partagée existe déjà</a:t>
             </a:r>
           </a:p>
         </p:txBody>
@@ -12233,7 +12233,7 @@
               </a:defRPr>
             </a:pPr>
             <a:r>
-              <a:t>›  3+ codebases consumers</a:t>
+              <a:t>›  Horizon long</a:t>
             </a:r>
           </a:p>
         </p:txBody>
@@ -12353,7 +12353,7 @@
               </a:defRPr>
             </a:pPr>
             <a:r>
-              <a:t>Allonge le break-even</a:t>
+              <a:t>Favorise la copie</a:t>
             </a:r>
           </a:p>
         </p:txBody>
@@ -12387,7 +12387,7 @@
               </a:defRPr>
             </a:pPr>
             <a:r>
-              <a:t>›  Feature petite et stable</a:t>
+              <a:t>›  Petite feature qui exige une nouvelle lib</a:t>
             </a:r>
           </a:p>
         </p:txBody>
@@ -12421,7 +12421,7 @@
               </a:defRPr>
             </a:pPr>
             <a:r>
-              <a:t>›  Coordination très coûteuse</a:t>
+              <a:t>›  Horizon court (1 an : il faut &gt; ~1 030 h)</a:t>
             </a:r>
           </a:p>
         </p:txBody>
@@ -12455,7 +12455,7 @@
               </a:defRPr>
             </a:pPr>
             <a:r>
-              <a:t>›  Codebases très différentes</a:t>
+              <a:t>›  Copies bon marché, ou généralisation coûteuse</a:t>
             </a:r>
           </a:p>
         </p:txBody>
@@ -12489,7 +12489,7 @@
               </a:defRPr>
             </a:pPr>
             <a:r>
-              <a:t>›  Feature en fin de vie</a:t>
+              <a:t>›  Copies censées diverger</a:t>
             </a:r>
           </a:p>
         </p:txBody>
@@ -12626,7 +12626,7 @@
               </a:defRPr>
             </a:pPr>
             <a:r>
-              <a:t>Plus on scale, plus le partage gagne</a:t>
+              <a:t>Plus d'apps, plus le partage gagne</a:t>
             </a:r>
           </a:p>
         </p:txBody>
@@ -12703,7 +12703,7 @@
               </a:defRPr>
             </a:pPr>
             <a:r>
-              <a:t>2 codebases</a:t>
+              <a:t>2 apps</a:t>
             </a:r>
           </a:p>
         </p:txBody>
@@ -12737,7 +12737,7 @@
               </a:defRPr>
             </a:pPr>
             <a:r>
-              <a:t>1.04x</a:t>
+              <a:t>1,07x</a:t>
             </a:r>
           </a:p>
         </p:txBody>
@@ -12805,11 +12805,11 @@
               </a:defRPr>
             </a:pPr>
             <a:r>
-              <a:t>Quasi équivalent</a:t>
+              <a:t>Le partage économise</a:t>
             </a:r>
             <a:br/>
             <a:r>
-              <a:t>sur 3 ans</a:t>
+              <a:t>~11 500 € sur 5 ans</a:t>
             </a:r>
           </a:p>
         </p:txBody>
@@ -12886,7 +12886,7 @@
               </a:defRPr>
             </a:pPr>
             <a:r>
-              <a:t>3 codebases</a:t>
+              <a:t>3 apps</a:t>
             </a:r>
           </a:p>
         </p:txBody>
@@ -12920,7 +12920,7 @@
               </a:defRPr>
             </a:pPr>
             <a:r>
-              <a:t>1.56x</a:t>
+              <a:t>1,41x</a:t>
             </a:r>
           </a:p>
         </p:txBody>
@@ -12992,7 +12992,7 @@
             </a:r>
             <a:br/>
             <a:r>
-              <a:t>~160 000€ sur 3 ans</a:t>
+              <a:t>~72 700 € sur 5 ans</a:t>
             </a:r>
           </a:p>
         </p:txBody>
@@ -13069,7 +13069,7 @@
               </a:defRPr>
             </a:pPr>
             <a:r>
-              <a:t>5 codebases</a:t>
+              <a:t>5 apps</a:t>
             </a:r>
           </a:p>
         </p:txBody>
@@ -13103,7 +13103,7 @@
               </a:defRPr>
             </a:pPr>
             <a:r>
-              <a:t>2.47x</a:t>
+              <a:t>1,92x</a:t>
             </a:r>
           </a:p>
         </p:txBody>
@@ -13171,11 +13171,11 @@
               </a:defRPr>
             </a:pPr>
             <a:r>
-              <a:t>La duplication coûte</a:t>
+              <a:t>Le partage économise</a:t>
             </a:r>
             <a:br/>
             <a:r>
-              <a:t>2.5x plus cher</a:t>
+              <a:t>~195 200 € sur 5 ans</a:t>
             </a:r>
           </a:p>
         </p:txBody>
@@ -13286,7 +13286,7 @@
               </a:defRPr>
             </a:pPr>
             <a:r>
-              <a:t>Avec du code dupliqué, chaque nouvelle codebase multiplie les coûts quasi-linéairement. Avec du code partagé, le coût marginal de chaque nouveau consumer est minimal (~5-10% du coût de portage).</a:t>
+              <a:t>Chaque copie supplémentaire coûte 65 % du build au départ, puis une part entière d'entretien chaque année (croissante avec la dérive). Chaque app supplémentaire sur une lib partagée coûte 20 % au départ, puis 4 %/an.</a:t>
             </a:r>
           </a:p>
         </p:txBody>
@@ -13389,7 +13389,7 @@
               </a:defRPr>
             </a:pPr>
             <a:r>
-              <a:t>IMPACT ORGANISATIONNEL</a:t>
+              <a:t>CONTRE-ARGUMENTS</a:t>
             </a:r>
           </a:p>
         </p:txBody>
@@ -13423,7 +13423,7 @@
               </a:defRPr>
             </a:pPr>
             <a:r>
-              <a:t>Au-delà du code : l'impact sur l'équipe</a:t>
+              <a:t>Ce que les chiffres ne disent pas</a:t>
             </a:r>
           </a:p>
         </p:txBody>
@@ -13543,7 +13543,7 @@
               </a:defRPr>
             </a:pPr>
             <a:r>
-              <a:t>Onboarding</a:t>
+              <a:t>Les clones sont souvent inoffensifs</a:t>
             </a:r>
           </a:p>
         </p:txBody>
@@ -13577,15 +13577,15 @@
               </a:defRPr>
             </a:pPr>
             <a:r>
-              <a:t>Code partagé : 1 source à apprendre</a:t>
+              <a:t>Jusqu'à 71 % des clones jugés bénéfiques</a:t>
             </a:r>
             <a:br/>
             <a:r>
-              <a:t>Code dupliqué : N sources + leurs différences</a:t>
+              <a:t>Pas plus sujets aux défauts (Rahman 2012)</a:t>
             </a:r>
             <a:br/>
             <a:r>
-              <a:t>→ +1-2 semaines d'onboarding avec duplication</a:t>
+              <a:t>→ Toute copie n'est pas un passif</a:t>
             </a:r>
           </a:p>
         </p:txBody>
@@ -13705,7 +13705,7 @@
               </a:defRPr>
             </a:pPr>
             <a:r>
-              <a:t>QA / Testing</a:t>
+              <a:t>La mauvaise abstraction</a:t>
             </a:r>
           </a:p>
         </p:txBody>
@@ -13739,15 +13739,15 @@
               </a:defRPr>
             </a:pPr>
             <a:r>
-              <a:t>Duplication = double effort de test</a:t>
+              <a:t>« Duplication is far cheaper than the</a:t>
             </a:r>
             <a:br/>
             <a:r>
-              <a:t>QA = 20-30% de l'effort dev (standard)</a:t>
+              <a:t>wrong abstraction » (Sandi Metz)</a:t>
             </a:r>
             <a:br/>
             <a:r>
-              <a:t>→ Doublé avec la duplication, pas avec le partage</a:t>
+              <a:t>→ Une copie censée diverger n'est pas un coût</a:t>
             </a:r>
           </a:p>
         </p:txBody>
@@ -13867,7 +13867,7 @@
               </a:defRPr>
             </a:pPr>
             <a:r>
-              <a:t>Product Management</a:t>
+              <a:t>Les breaking changes</a:t>
             </a:r>
           </a:p>
         </p:txBody>
@@ -13901,15 +13901,15 @@
               </a:defRPr>
             </a:pPr>
             <a:r>
-              <a:t>Partagé : 1 backlog unifié</a:t>
+              <a:t>14,8 % des changements d'API cassent (Xavier 2017)</a:t>
             </a:r>
             <a:br/>
             <a:r>
-              <a:t>Dupliqué : 2 backlogs à coordonner</a:t>
+              <a:t>81,5 % des systèmes ont des deps obsolètes (Kula 2018)</a:t>
             </a:r>
             <a:br/>
             <a:r>
-              <a:t>→ Gestion d'incidents 1.5-2x plus coûteuse</a:t>
+              <a:t>→ Chiffré grossièrement : 4 %/an par app</a:t>
             </a:r>
           </a:p>
         </p:txBody>
@@ -14029,7 +14029,7 @@
               </a:defRPr>
             </a:pPr>
             <a:r>
-              <a:t>Cohérence UX</a:t>
+              <a:t>Hors modèle</a:t>
             </a:r>
           </a:p>
         </p:txBody>
@@ -14063,15 +14063,15 @@
               </a:defRPr>
             </a:pPr>
             <a:r>
-              <a:t>Partagé : garantie par le code</a:t>
+              <a:t>Time-to-market, goulot de release</a:t>
             </a:r>
             <a:br/>
             <a:r>
-              <a:t>Dupliqué : dégradation progressive</a:t>
+              <a:t>Cohérence UX, divergence voulue</a:t>
             </a:r>
             <a:br/>
             <a:r>
-              <a:t>→ Les copies divergent inévitablement</a:t>
+              <a:t>→ Pas d'actualisation (VAN) non plus</a:t>
             </a:r>
           </a:p>
         </p:txBody>

</xml_diff>

<commit_message>
fix: handle exact ties in break-even and verdict wording
- relative tolerance so a tie at month 0 never becomes 'after 1 month'
- 'From the start' for a tie, 'From day one' only when strictly cheaper
- equal totals no longer read as 'Sharing costs you + 0 €'
- notes, script, decks: e0 < 0.75 threshold, 16,751 €/yr, porting
  factor described as within the measured range
</commit_message>
<xml_diff>
--- a/docs/FR/Cout-Feature-Partage-vs-Duplication.pptx
+++ b/docs/FR/Cout-Feature-Partage-vs-Duplication.pptx
@@ -5862,7 +5862,7 @@
               </a:defRPr>
             </a:pPr>
             <a:r>
-              <a:t>Dès le jour 0 (cas de référence)</a:t>
+              <a:t>Dès le départ (cas de référence)</a:t>
             </a:r>
           </a:p>
         </p:txBody>
@@ -10027,7 +10027,7 @@
               </a:defRPr>
             </a:pPr>
             <a:r>
-              <a:t>Cas de référence : partage 16 750 €/an vs duplication 18 144 € → 19 958 €/an, payés chaque année</a:t>
+              <a:t>Cas de référence : partage 16 751 €/an vs duplication 18 144 € → 19 958 €/an, payés chaque année</a:t>
             </a:r>
           </a:p>
         </p:txBody>
@@ -11504,7 +11504,7 @@
               </a:defRPr>
             </a:pPr>
             <a:r>
-              <a:t>›  Le partage n'est jamais plus cher : il est rentable dès le jour 0</a:t>
+              <a:t>›  Le partage n'est jamais plus cher : il est rentable dès le départ</a:t>
             </a:r>
           </a:p>
         </p:txBody>
@@ -11572,7 +11572,7 @@
               </a:defRPr>
             </a:pPr>
             <a:r>
-              <a:t>›  Marge mince pour 2 apps : une généralisation G ≥ 1,33 ou un entretien de copie e0 ≤ 0,75 inverse le verdict</a:t>
+              <a:t>›  Marge mince pour 2 apps : une généralisation G ≥ 1,33 ou un entretien de copie e0 &lt; 0,75 inverse le verdict</a:t>
             </a:r>
           </a:p>
         </p:txBody>

</xml_diff>